<commit_message>
docs(demo): show GitOps with Argo CD in the deck and evidence
Architecture and CI/CD slides now show the GitOps deploy, a new slide
covers Argo CD, and the closing slide links this repository.
</commit_message>
<xml_diff>
--- a/demo/HelpDesk-Presentation.pptx
+++ b/demo/HelpDesk-Presentation.pptx
@@ -19,9 +19,10 @@
     <p:sldId id="267" r:id="rId13"/>
     <p:sldId id="268" r:id="rId14"/>
     <p:sldId id="269" r:id="rId15"/>
+    <p:sldId id="270" r:id="rId16"/>
   </p:sldIdLst>
   <p:notesMasterIdLst>
-    <p:notesMasterId r:id="rId16"/>
+    <p:notesMasterId r:id="rId17"/>
   </p:notesMasterIdLst>
   <p:sldSz cx="9144000" cy="5143500"/>
   <p:notesSz cx="5143500" cy="9144000"/>
@@ -120,42 +121,43 @@
   <p:extLst>
     <p:ext uri="{521415D9-36F7-43E2-AB2F-B90AF26B5E84}">
       <p14:sectionLst xmlns:p14="http://schemas.microsoft.com/office/powerpoint/2010/main">
-        <p14:section name="Introduction" id="{f7d1a902-3353-aa39-9828-3c9583c81307}">
+        <p14:section name="Introduction" id="{a51407f5-1ed0-47d0-3336-f2ec08b45cb8}">
           <p14:sldIdLst>
             <p14:sldId id="256"/>
             <p14:sldId id="257"/>
           </p14:sldIdLst>
         </p14:section>
-        <p14:section name="Architecture" id="{1b584140-7cf3-cc38-87cb-cf32fe5be9b2}">
+        <p14:section name="Architecture" id="{d267dfcd-63d4-91a1-a80a-d39765ae9ca1}">
           <p14:sldIdLst>
             <p14:sldId id="258"/>
             <p14:sldId id="259"/>
           </p14:sldIdLst>
         </p14:section>
-        <p14:section name="Build" id="{f0b335aa-3384-aaa9-a5e2-363b595ef907}">
+        <p14:section name="Build" id="{ca06ab74-505d-f724-acf7-b2294b5a6835}">
           <p14:sldIdLst>
             <p14:sldId id="260"/>
             <p14:sldId id="261"/>
             <p14:sldId id="262"/>
           </p14:sldIdLst>
         </p14:section>
-        <p14:section name="Ship" id="{8100e104-d5a8-f8ad-1323-a67388bb18d1}">
+        <p14:section name="Ship" id="{5a7044bc-2eb1-cca2-e1b1-38555e5ee8f2}">
           <p14:sldIdLst>
             <p14:sldId id="263"/>
             <p14:sldId id="264"/>
           </p14:sldIdLst>
         </p14:section>
-        <p14:section name="Run on AWS" id="{19c7243f-b1a2-284d-6983-734e1d248d7e}">
+        <p14:section name="Run on AWS" id="{622b4e6d-7a05-8801-b2b9-8a81169a09ca}">
           <p14:sldIdLst>
             <p14:sldId id="265"/>
             <p14:sldId id="266"/>
             <p14:sldId id="267"/>
+            <p14:sldId id="268"/>
           </p14:sldIdLst>
         </p14:section>
-        <p14:section name="Wrap-up" id="{978cbf9c-254a-f2f5-4ec5-9f78da94a617}">
+        <p14:section name="Wrap-up" id="{f217e0aa-e41d-705f-a301-0801ea9701bb}">
           <p14:sldIdLst>
-            <p14:sldId id="268"/>
             <p14:sldId id="269"/>
+            <p14:sldId id="270"/>
           </p14:sldIdLst>
         </p14:section>
       </p14:sectionLst>
@@ -826,7 +828,7 @@
           <a:p>
             <a:r>
               <a:rPr lang="en-US" dirty="0"/>
-              <a:t>Part 10: Autoscaling and monitoring.</a:t>
+              <a:t>Part 8b: GitOps with Argo CD.</a:t>
             </a:r>
             <a:endParaRPr lang="en-US" dirty="0"/>
           </a:p>
@@ -914,7 +916,7 @@
           <a:p>
             <a:r>
               <a:rPr lang="en-US" dirty="0"/>
-              <a:t>Part 11: Challenges and what I learned.</a:t>
+              <a:t>Part 10: Autoscaling and monitoring.</a:t>
             </a:r>
             <a:endParaRPr lang="en-US" dirty="0"/>
           </a:p>
@@ -1002,7 +1004,7 @@
           <a:p>
             <a:r>
               <a:rPr lang="en-US" dirty="0"/>
-              <a:t>Part 12: Cleanup and thank you.</a:t>
+              <a:t>Part 11: Challenges and what I learned.</a:t>
             </a:r>
             <a:endParaRPr lang="en-US" dirty="0"/>
           </a:p>
@@ -1026,6 +1028,94 @@
             <a:fld id="{F7021451-1387-4CA6-816F-3879F97B5CBC}" type="slidenum">
               <a:rPr lang="en-US"/>
               <a:t>14</a:t>
+            </a:fld>
+            <a:endParaRPr lang="en-US"/>
+          </a:p>
+        </p:txBody>
+      </p:sp>
+    </p:spTree>
+    <p:extLst>
+      <p:ext uri="{BB962C8B-B14F-4D97-AF65-F5344CB8AC3E}">
+        <p14:creationId xmlns:p14="http://schemas.microsoft.com/office/powerpoint/2010/main" val="1024086991"/>
+      </p:ext>
+    </p:extLst>
+  </p:cSld>
+  <p:clrMapOvr>
+    <a:masterClrMapping/>
+  </p:clrMapOvr>
+</p:notes>
+</file>
+
+<file path=ppt/notesSlides/notesSlide15.xml><?xml version="1.0" encoding="utf-8"?>
+<p:notes xmlns:a="http://schemas.openxmlformats.org/drawingml/2006/main" xmlns:r="http://schemas.openxmlformats.org/officeDocument/2006/relationships" xmlns:p="http://schemas.openxmlformats.org/presentationml/2006/main">
+  <p:cSld>
+    <p:spTree>
+      <p:nvGrpSpPr>
+        <p:cNvPr id="1" name=""/>
+        <p:cNvGrpSpPr/>
+        <p:nvPr/>
+      </p:nvGrpSpPr>
+      <p:grpSpPr>
+        <a:xfrm>
+          <a:off x="0" y="0"/>
+          <a:ext cx="0" cy="0"/>
+          <a:chOff x="0" y="0"/>
+          <a:chExt cx="0" cy="0"/>
+        </a:xfrm>
+      </p:grpSpPr>
+      <p:sp>
+        <p:nvSpPr>
+          <p:cNvPr id="2" name="Slide Image Placeholder 1"/>
+          <p:cNvSpPr>
+            <a:spLocks noGrp="1" noRot="1" noChangeAspect="1"/>
+          </p:cNvSpPr>
+          <p:nvPr>
+            <p:ph type="sldImg"/>
+          </p:nvPr>
+        </p:nvSpPr>
+        <p:spPr/>
+      </p:sp>
+      <p:sp>
+        <p:nvSpPr>
+          <p:cNvPr id="3" name="Notes Placeholder 2"/>
+          <p:cNvSpPr>
+            <a:spLocks noGrp="1"/>
+          </p:cNvSpPr>
+          <p:nvPr>
+            <p:ph type="body" idx="1"/>
+          </p:nvPr>
+        </p:nvSpPr>
+        <p:spPr/>
+        <p:txBody>
+          <a:bodyPr/>
+          <a:lstStyle/>
+          <a:p>
+            <a:r>
+              <a:rPr lang="en-US" dirty="0"/>
+              <a:t>Part 12: Cleanup and thank you.</a:t>
+            </a:r>
+            <a:endParaRPr lang="en-US" dirty="0"/>
+          </a:p>
+        </p:txBody>
+      </p:sp>
+      <p:sp>
+        <p:nvSpPr>
+          <p:cNvPr id="4" name="Slide Number Placeholder 3"/>
+          <p:cNvSpPr>
+            <a:spLocks noGrp="1"/>
+          </p:cNvSpPr>
+          <p:nvPr>
+            <p:ph type="sldNum" sz="quarter" idx="10"/>
+          </p:nvPr>
+        </p:nvSpPr>
+        <p:spPr/>
+        <p:txBody>
+          <a:bodyPr/>
+          <a:lstStyle/>
+          <a:p>
+            <a:fld id="{F7021451-1387-4CA6-816F-3879F97B5CBC}" type="slidenum">
+              <a:rPr lang="en-US"/>
+              <a:t>15</a:t>
             </a:fld>
             <a:endParaRPr lang="en-US"/>
           </a:p>
@@ -3461,7 +3551,7 @@
                   <a:schemeClr val="tx2"/>
                 </a:solidFill>
               </a:rPr>
-              <a:t>Autoscaling and monitoring</a:t>
+              <a:t>GitOps with Argo CD</a:t>
             </a:r>
             <a:endParaRPr lang="en-US" sz="2800" dirty="0"/>
           </a:p>
@@ -3517,7 +3607,7 @@
                   <a:schemeClr val="bg1"/>
                 </a:solidFill>
               </a:rPr>
-              <a:t>M9</a:t>
+              <a:t>M8</a:t>
             </a:r>
             <a:endParaRPr lang="en-US" sz="1200" dirty="0"/>
           </a:p>
@@ -3525,18 +3615,18 @@
       </p:sp>
       <p:sp>
         <p:nvSpPr>
-          <p:cNvPr id="5" name="Grafana HelpDesk dashboard frame"/>
+          <p:cNvPr id="5" name="Argo CD helpdesk application tree frame"/>
           <p:cNvSpPr/>
           <p:nvPr/>
         </p:nvSpPr>
         <p:spPr>
           <a:xfrm>
-            <a:off x="535838" y="960120"/>
-            <a:ext cx="4323283" cy="2743200"/>
+            <a:off x="411480" y="1360954"/>
+            <a:ext cx="5394960" cy="2810212"/>
           </a:xfrm>
           <a:prstGeom prst="roundRect">
             <a:avLst>
-              <a:gd name="adj" fmla="val 2000"/>
+              <a:gd name="adj" fmla="val 1952"/>
             </a:avLst>
           </a:prstGeom>
           <a:solidFill>
@@ -3559,7 +3649,7 @@
       </p:sp>
       <p:pic>
         <p:nvPicPr>
-          <p:cNvPr id="6" name="Grafana HelpDesk dashboard" descr="Grafana HelpDesk dashboard">    </p:cNvPr>
+          <p:cNvPr id="6" name="Argo CD helpdesk application tree" descr="Argo CD helpdesk application tree">    </p:cNvPr>
           <p:cNvPicPr>
             <a:picLocks noChangeAspect="1"/>
           </p:cNvPicPr>
@@ -3573,8 +3663,8 @@
         </p:blipFill>
         <p:spPr>
           <a:xfrm>
-            <a:off x="590702" y="1014984"/>
-            <a:ext cx="4213555" cy="2633472"/>
+            <a:off x="466344" y="1415818"/>
+            <a:ext cx="5285232" cy="2700484"/>
           </a:xfrm>
           <a:prstGeom prst="rect">
             <a:avLst/>
@@ -3583,14 +3673,14 @@
       </p:pic>
       <p:sp>
         <p:nvSpPr>
-          <p:cNvPr id="7" name="stat Prometheus targets UP"/>
-          <p:cNvSpPr txBox="1"/>
-          <p:nvPr/>
-        </p:nvSpPr>
-        <p:spPr>
-          <a:xfrm>
-            <a:off x="5257800" y="1051560"/>
-            <a:ext cx="1645920" cy="566928"/>
+          <p:cNvPr id="7" name="argo step 1 title"/>
+          <p:cNvSpPr txBox="1"/>
+          <p:nvPr/>
+        </p:nvSpPr>
+        <p:spPr>
+          <a:xfrm>
+            <a:off x="6080760" y="1051560"/>
+            <a:ext cx="2651760" cy="310896"/>
           </a:xfrm>
           <a:prstGeom prst="rect">
             <a:avLst/>
@@ -3606,30 +3696,27 @@
               <a:buNone/>
             </a:pPr>
             <a:r>
-              <a:rPr lang="en-US" sz="3200" b="1" dirty="0">
-                <a:solidFill>
-                  <a:schemeClr val="accent1"/>
-                </a:solidFill>
-                <a:latin typeface="Arial" pitchFamily="34" charset="0"/>
-                <a:ea typeface="Arial" pitchFamily="34" charset="-122"/>
-                <a:cs typeface="Arial" pitchFamily="34" charset="-120"/>
-              </a:rPr>
-              <a:t>2 / 2</a:t>
-            </a:r>
-            <a:endParaRPr lang="en-US" sz="3200" dirty="0"/>
-          </a:p>
-        </p:txBody>
-      </p:sp>
-      <p:sp>
-        <p:nvSpPr>
-          <p:cNvPr id="8" name="stat label Prometheus targets UP"/>
-          <p:cNvSpPr txBox="1"/>
-          <p:nvPr/>
-        </p:nvSpPr>
-        <p:spPr>
-          <a:xfrm>
-            <a:off x="5257800" y="1618488"/>
-            <a:ext cx="1645920" cy="457200"/>
+              <a:rPr lang="en-US" sz="1500" b="1" dirty="0">
+                <a:solidFill>
+                  <a:schemeClr val="tx2"/>
+                </a:solidFill>
+              </a:rPr>
+              <a:t>Git is the source of truth</a:t>
+            </a:r>
+            <a:endParaRPr lang="en-US" sz="1500" dirty="0"/>
+          </a:p>
+        </p:txBody>
+      </p:sp>
+      <p:sp>
+        <p:nvSpPr>
+          <p:cNvPr id="8" name="argo step 1 text"/>
+          <p:cNvSpPr txBox="1"/>
+          <p:nvPr/>
+        </p:nvSpPr>
+        <p:spPr>
+          <a:xfrm>
+            <a:off x="6080760" y="1380744"/>
+            <a:ext cx="2651760" cy="731520"/>
           </a:xfrm>
           <a:prstGeom prst="rect">
             <a:avLst/>
@@ -3650,7 +3737,7 @@
                   <a:schemeClr val="tx1"/>
                 </a:solidFill>
               </a:rPr>
-              <a:t>Prometheus targets UP</a:t>
+              <a:t>Argo CD watches helm/helpdesk on main and keeps the cluster equal to it</a:t>
             </a:r>
             <a:endParaRPr lang="en-US" sz="1300" dirty="0"/>
           </a:p>
@@ -3658,14 +3745,14 @@
       </p:sp>
       <p:sp>
         <p:nvSpPr>
-          <p:cNvPr id="9" name="stat backend pods via HPA at 60% CPU"/>
-          <p:cNvSpPr txBox="1"/>
-          <p:nvPr/>
-        </p:nvSpPr>
-        <p:spPr>
-          <a:xfrm>
-            <a:off x="7086600" y="1051560"/>
-            <a:ext cx="1645920" cy="566928"/>
+          <p:cNvPr id="9" name="argo step 2 title"/>
+          <p:cNvSpPr txBox="1"/>
+          <p:nvPr/>
+        </p:nvSpPr>
+        <p:spPr>
+          <a:xfrm>
+            <a:off x="6080760" y="2240280"/>
+            <a:ext cx="2651760" cy="310896"/>
           </a:xfrm>
           <a:prstGeom prst="rect">
             <a:avLst/>
@@ -3681,30 +3768,27 @@
               <a:buNone/>
             </a:pPr>
             <a:r>
-              <a:rPr lang="en-US" sz="3200" b="1" dirty="0">
-                <a:solidFill>
-                  <a:schemeClr val="accent1"/>
-                </a:solidFill>
-                <a:latin typeface="Arial" pitchFamily="34" charset="0"/>
-                <a:ea typeface="Arial" pitchFamily="34" charset="-122"/>
-                <a:cs typeface="Arial" pitchFamily="34" charset="-120"/>
-              </a:rPr>
-              <a:t>2 → 6</a:t>
-            </a:r>
-            <a:endParaRPr lang="en-US" sz="3200" dirty="0"/>
-          </a:p>
-        </p:txBody>
-      </p:sp>
-      <p:sp>
-        <p:nvSpPr>
-          <p:cNvPr id="10" name="stat label backend pods via HPA at 60% CPU"/>
-          <p:cNvSpPr txBox="1"/>
-          <p:nvPr/>
-        </p:nvSpPr>
-        <p:spPr>
-          <a:xfrm>
-            <a:off x="7086600" y="1618488"/>
-            <a:ext cx="1645920" cy="457200"/>
+              <a:rPr lang="en-US" sz="1500" b="1" dirty="0">
+                <a:solidFill>
+                  <a:schemeClr val="tx2"/>
+                </a:solidFill>
+              </a:rPr>
+              <a:t>CI only commits</a:t>
+            </a:r>
+            <a:endParaRPr lang="en-US" sz="1500" dirty="0"/>
+          </a:p>
+        </p:txBody>
+      </p:sp>
+      <p:sp>
+        <p:nvSpPr>
+          <p:cNvPr id="10" name="argo step 2 text"/>
+          <p:cNvSpPr txBox="1"/>
+          <p:nvPr/>
+        </p:nvSpPr>
+        <p:spPr>
+          <a:xfrm>
+            <a:off x="6080760" y="2569464"/>
+            <a:ext cx="2651760" cy="731520"/>
           </a:xfrm>
           <a:prstGeom prst="rect">
             <a:avLst/>
@@ -3725,7 +3809,7 @@
                   <a:schemeClr val="tx1"/>
                 </a:solidFill>
               </a:rPr>
-              <a:t>backend pods via HPA at 60% CPU</a:t>
+              <a:t>after tests + Trivy, CI writes the new SHA to values-image.yaml</a:t>
             </a:r>
             <a:endParaRPr lang="en-US" sz="1300" dirty="0"/>
           </a:p>
@@ -3733,14 +3817,14 @@
       </p:sp>
       <p:sp>
         <p:nvSpPr>
-          <p:cNvPr id="11" name="stat 5xx error ratio"/>
-          <p:cNvSpPr txBox="1"/>
-          <p:nvPr/>
-        </p:nvSpPr>
-        <p:spPr>
-          <a:xfrm>
-            <a:off x="5257800" y="2331720"/>
-            <a:ext cx="1645920" cy="566928"/>
+          <p:cNvPr id="11" name="argo step 3 title"/>
+          <p:cNvSpPr txBox="1"/>
+          <p:nvPr/>
+        </p:nvSpPr>
+        <p:spPr>
+          <a:xfrm>
+            <a:off x="6080760" y="3429000"/>
+            <a:ext cx="2651760" cy="310896"/>
           </a:xfrm>
           <a:prstGeom prst="rect">
             <a:avLst/>
@@ -3756,30 +3840,27 @@
               <a:buNone/>
             </a:pPr>
             <a:r>
-              <a:rPr lang="en-US" sz="3200" b="1" dirty="0">
-                <a:solidFill>
-                  <a:schemeClr val="accent1"/>
-                </a:solidFill>
-                <a:latin typeface="Arial" pitchFamily="34" charset="0"/>
-                <a:ea typeface="Arial" pitchFamily="34" charset="-122"/>
-                <a:cs typeface="Arial" pitchFamily="34" charset="-120"/>
-              </a:rPr>
-              <a:t>0 %</a:t>
-            </a:r>
-            <a:endParaRPr lang="en-US" sz="3200" dirty="0"/>
-          </a:p>
-        </p:txBody>
-      </p:sp>
-      <p:sp>
-        <p:nvSpPr>
-          <p:cNvPr id="12" name="stat label 5xx error ratio"/>
-          <p:cNvSpPr txBox="1"/>
-          <p:nvPr/>
-        </p:nvSpPr>
-        <p:spPr>
-          <a:xfrm>
-            <a:off x="5257800" y="2898648"/>
-            <a:ext cx="1645920" cy="457200"/>
+              <a:rPr lang="en-US" sz="1500" b="1" dirty="0">
+                <a:solidFill>
+                  <a:schemeClr val="tx2"/>
+                </a:solidFill>
+              </a:rPr>
+              <a:t>Auto-sync + self-heal</a:t>
+            </a:r>
+            <a:endParaRPr lang="en-US" sz="1500" dirty="0"/>
+          </a:p>
+        </p:txBody>
+      </p:sp>
+      <p:sp>
+        <p:nvSpPr>
+          <p:cNvPr id="12" name="argo step 3 text"/>
+          <p:cNvSpPr txBox="1"/>
+          <p:nvPr/>
+        </p:nvSpPr>
+        <p:spPr>
+          <a:xfrm>
+            <a:off x="6080760" y="3758184"/>
+            <a:ext cx="2651760" cy="731520"/>
           </a:xfrm>
           <a:prstGeom prst="rect">
             <a:avLst/>
@@ -3800,145 +3881,12 @@
                   <a:schemeClr val="tx1"/>
                 </a:solidFill>
               </a:rPr>
-              <a:t>5xx error ratio</a:t>
+              <a:t>manual cluster edits are reverted; rollback = git revert</a:t>
             </a:r>
             <a:endParaRPr lang="en-US" sz="1300" dirty="0"/>
           </a:p>
         </p:txBody>
       </p:sp>
-      <p:sp>
-        <p:nvSpPr>
-          <p:cNvPr id="13" name="stat p95 latency under load"/>
-          <p:cNvSpPr txBox="1"/>
-          <p:nvPr/>
-        </p:nvSpPr>
-        <p:spPr>
-          <a:xfrm>
-            <a:off x="7086600" y="2331720"/>
-            <a:ext cx="1645920" cy="566928"/>
-          </a:xfrm>
-          <a:prstGeom prst="rect">
-            <a:avLst/>
-          </a:prstGeom>
-          <a:noFill/>
-          <a:ln/>
-        </p:spPr>
-        <p:txBody>
-          <a:bodyPr wrap="square" lIns="0" tIns="0" rIns="0" bIns="0" rtlCol="0" anchor="ctr"/>
-          <a:lstStyle/>
-          <a:p>
-            <a:pPr indent="0" marL="0">
-              <a:buNone/>
-            </a:pPr>
-            <a:r>
-              <a:rPr lang="en-US" sz="3200" b="1" dirty="0">
-                <a:solidFill>
-                  <a:schemeClr val="accent1"/>
-                </a:solidFill>
-                <a:latin typeface="Arial" pitchFamily="34" charset="0"/>
-                <a:ea typeface="Arial" pitchFamily="34" charset="-122"/>
-                <a:cs typeface="Arial" pitchFamily="34" charset="-120"/>
-              </a:rPr>
-              <a:t>95 ms</a:t>
-            </a:r>
-            <a:endParaRPr lang="en-US" sz="3200" dirty="0"/>
-          </a:p>
-        </p:txBody>
-      </p:sp>
-      <p:sp>
-        <p:nvSpPr>
-          <p:cNvPr id="14" name="stat label p95 latency under load"/>
-          <p:cNvSpPr txBox="1"/>
-          <p:nvPr/>
-        </p:nvSpPr>
-        <p:spPr>
-          <a:xfrm>
-            <a:off x="7086600" y="2898648"/>
-            <a:ext cx="1645920" cy="457200"/>
-          </a:xfrm>
-          <a:prstGeom prst="rect">
-            <a:avLst/>
-          </a:prstGeom>
-          <a:noFill/>
-          <a:ln/>
-        </p:spPr>
-        <p:txBody>
-          <a:bodyPr wrap="square" lIns="0" tIns="0" rIns="0" bIns="0" rtlCol="0" anchor="t"/>
-          <a:lstStyle/>
-          <a:p>
-            <a:pPr indent="0" marL="0">
-              <a:buNone/>
-            </a:pPr>
-            <a:r>
-              <a:rPr lang="en-US" sz="1300" dirty="0">
-                <a:solidFill>
-                  <a:schemeClr val="tx1"/>
-                </a:solidFill>
-              </a:rPr>
-              <a:t>p95 latency under load</a:t>
-            </a:r>
-            <a:endParaRPr lang="en-US" sz="1300" dirty="0"/>
-          </a:p>
-        </p:txBody>
-      </p:sp>
-      <p:sp>
-        <p:nvSpPr>
-          <p:cNvPr id="15" name="Prometheus targets UP frame"/>
-          <p:cNvSpPr/>
-          <p:nvPr/>
-        </p:nvSpPr>
-        <p:spPr>
-          <a:xfrm>
-            <a:off x="2022653" y="3749040"/>
-            <a:ext cx="5098694" cy="960120"/>
-          </a:xfrm>
-          <a:prstGeom prst="roundRect">
-            <a:avLst>
-              <a:gd name="adj" fmla="val 5714"/>
-            </a:avLst>
-          </a:prstGeom>
-          <a:solidFill>
-            <a:srgbClr val="FFFFFF"/>
-          </a:solidFill>
-          <a:ln w="9525">
-            <a:solidFill>
-              <a:srgbClr val="D5DEDD"/>
-            </a:solidFill>
-            <a:prstDash val="solid"/>
-          </a:ln>
-          <a:effectLst>
-            <a:outerShdw sx="100000" sy="100000" kx="0" ky="0" algn="bl" rotWithShape="0" blurRad="76200" dist="25400" dir="5400000">
-              <a:srgbClr val="000000">
-                <a:alpha val="18000"/>
-              </a:srgbClr>
-            </a:outerShdw>
-          </a:effectLst>
-        </p:spPr>
-      </p:sp>
-      <p:pic>
-        <p:nvPicPr>
-          <p:cNvPr id="16" name="Prometheus targets UP" descr="Prometheus targets UP">    </p:cNvPr>
-          <p:cNvPicPr>
-            <a:picLocks noChangeAspect="1"/>
-          </p:cNvPicPr>
-          <p:nvPr/>
-        </p:nvPicPr>
-        <p:blipFill>
-          <a:blip r:embed="rId2"/>
-          <a:stretch>
-            <a:fillRect/>
-          </a:stretch>
-        </p:blipFill>
-        <p:spPr>
-          <a:xfrm>
-            <a:off x="2077517" y="3803904"/>
-            <a:ext cx="4988966" cy="850392"/>
-          </a:xfrm>
-          <a:prstGeom prst="rect">
-            <a:avLst/>
-          </a:prstGeom>
-        </p:spPr>
-      </p:pic>
       <p:sp>
         <p:nvSpPr>
           <p:cNvPr id="25" name="Slide Number Placeholder 0"/>
@@ -4041,7 +3989,7 @@
                   <a:schemeClr val="tx2"/>
                 </a:solidFill>
               </a:rPr>
-              <a:t>Real problems I solved</a:t>
+              <a:t>Autoscaling and monitoring</a:t>
             </a:r>
             <a:endParaRPr lang="en-US" sz="2800" dirty="0"/>
           </a:p>
@@ -4097,7 +4045,7 @@
                   <a:schemeClr val="bg1"/>
                 </a:solidFill>
               </a:rPr>
-              <a:t>!</a:t>
+              <a:t>M9</a:t>
             </a:r>
             <a:endParaRPr lang="en-US" sz="1200" dirty="0"/>
           </a:p>
@@ -4105,604 +4053,420 @@
       </p:sp>
       <p:sp>
         <p:nvSpPr>
-          <p:cNvPr id="5" name="challenge 1 card"/>
+          <p:cNvPr id="5" name="Grafana HelpDesk dashboard frame"/>
           <p:cNvSpPr/>
           <p:nvPr/>
         </p:nvSpPr>
         <p:spPr>
           <a:xfrm>
-            <a:off x="457200" y="1051560"/>
-            <a:ext cx="4023360" cy="1645920"/>
+            <a:off x="535838" y="960120"/>
+            <a:ext cx="4323283" cy="2743200"/>
           </a:xfrm>
           <a:prstGeom prst="roundRect">
             <a:avLst>
-              <a:gd name="adj" fmla="val 4444"/>
+              <a:gd name="adj" fmla="val 2000"/>
             </a:avLst>
           </a:prstGeom>
           <a:solidFill>
-            <a:schemeClr val="bg2"/>
+            <a:srgbClr val="FFFFFF"/>
           </a:solidFill>
-          <a:ln/>
-        </p:spPr>
-      </p:sp>
-      <p:sp>
-        <p:nvSpPr>
-          <p:cNvPr id="6" name="challenge 1 chip"/>
+          <a:ln w="9525">
+            <a:solidFill>
+              <a:srgbClr val="D5DEDD"/>
+            </a:solidFill>
+            <a:prstDash val="solid"/>
+          </a:ln>
+          <a:effectLst>
+            <a:outerShdw sx="100000" sy="100000" kx="0" ky="0" algn="bl" rotWithShape="0" blurRad="76200" dist="25400" dir="5400000">
+              <a:srgbClr val="000000">
+                <a:alpha val="18000"/>
+              </a:srgbClr>
+            </a:outerShdw>
+          </a:effectLst>
+        </p:spPr>
+      </p:sp>
+      <p:pic>
+        <p:nvPicPr>
+          <p:cNvPr id="6" name="Grafana HelpDesk dashboard" descr="Grafana HelpDesk dashboard">    </p:cNvPr>
+          <p:cNvPicPr>
+            <a:picLocks noChangeAspect="1"/>
+          </p:cNvPicPr>
+          <p:nvPr/>
+        </p:nvPicPr>
+        <p:blipFill>
+          <a:blip r:embed="rId1"/>
+          <a:stretch>
+            <a:fillRect/>
+          </a:stretch>
+        </p:blipFill>
+        <p:spPr>
+          <a:xfrm>
+            <a:off x="590702" y="1014984"/>
+            <a:ext cx="4213555" cy="2633472"/>
+          </a:xfrm>
+          <a:prstGeom prst="rect">
+            <a:avLst/>
+          </a:prstGeom>
+        </p:spPr>
+      </p:pic>
+      <p:sp>
+        <p:nvSpPr>
+          <p:cNvPr id="7" name="stat Prometheus targets UP"/>
+          <p:cNvSpPr txBox="1"/>
+          <p:nvPr/>
+        </p:nvSpPr>
+        <p:spPr>
+          <a:xfrm>
+            <a:off x="5257800" y="1051560"/>
+            <a:ext cx="1645920" cy="566928"/>
+          </a:xfrm>
+          <a:prstGeom prst="rect">
+            <a:avLst/>
+          </a:prstGeom>
+          <a:noFill/>
+          <a:ln/>
+        </p:spPr>
+        <p:txBody>
+          <a:bodyPr wrap="square" lIns="0" tIns="0" rIns="0" bIns="0" rtlCol="0" anchor="ctr"/>
+          <a:lstStyle/>
+          <a:p>
+            <a:pPr indent="0" marL="0">
+              <a:buNone/>
+            </a:pPr>
+            <a:r>
+              <a:rPr lang="en-US" sz="3200" b="1" dirty="0">
+                <a:solidFill>
+                  <a:schemeClr val="accent1"/>
+                </a:solidFill>
+                <a:latin typeface="Arial" pitchFamily="34" charset="0"/>
+                <a:ea typeface="Arial" pitchFamily="34" charset="-122"/>
+                <a:cs typeface="Arial" pitchFamily="34" charset="-120"/>
+              </a:rPr>
+              <a:t>2 / 2</a:t>
+            </a:r>
+            <a:endParaRPr lang="en-US" sz="3200" dirty="0"/>
+          </a:p>
+        </p:txBody>
+      </p:sp>
+      <p:sp>
+        <p:nvSpPr>
+          <p:cNvPr id="8" name="stat label Prometheus targets UP"/>
+          <p:cNvSpPr txBox="1"/>
+          <p:nvPr/>
+        </p:nvSpPr>
+        <p:spPr>
+          <a:xfrm>
+            <a:off x="5257800" y="1618488"/>
+            <a:ext cx="1645920" cy="457200"/>
+          </a:xfrm>
+          <a:prstGeom prst="rect">
+            <a:avLst/>
+          </a:prstGeom>
+          <a:noFill/>
+          <a:ln/>
+        </p:spPr>
+        <p:txBody>
+          <a:bodyPr wrap="square" lIns="0" tIns="0" rIns="0" bIns="0" rtlCol="0" anchor="t"/>
+          <a:lstStyle/>
+          <a:p>
+            <a:pPr indent="0" marL="0">
+              <a:buNone/>
+            </a:pPr>
+            <a:r>
+              <a:rPr lang="en-US" sz="1300" dirty="0">
+                <a:solidFill>
+                  <a:schemeClr val="tx1"/>
+                </a:solidFill>
+              </a:rPr>
+              <a:t>Prometheus targets UP</a:t>
+            </a:r>
+            <a:endParaRPr lang="en-US" sz="1300" dirty="0"/>
+          </a:p>
+        </p:txBody>
+      </p:sp>
+      <p:sp>
+        <p:nvSpPr>
+          <p:cNvPr id="9" name="stat backend pods via HPA at 60% CPU"/>
+          <p:cNvSpPr txBox="1"/>
+          <p:nvPr/>
+        </p:nvSpPr>
+        <p:spPr>
+          <a:xfrm>
+            <a:off x="7086600" y="1051560"/>
+            <a:ext cx="1645920" cy="566928"/>
+          </a:xfrm>
+          <a:prstGeom prst="rect">
+            <a:avLst/>
+          </a:prstGeom>
+          <a:noFill/>
+          <a:ln/>
+        </p:spPr>
+        <p:txBody>
+          <a:bodyPr wrap="square" lIns="0" tIns="0" rIns="0" bIns="0" rtlCol="0" anchor="ctr"/>
+          <a:lstStyle/>
+          <a:p>
+            <a:pPr indent="0" marL="0">
+              <a:buNone/>
+            </a:pPr>
+            <a:r>
+              <a:rPr lang="en-US" sz="3200" b="1" dirty="0">
+                <a:solidFill>
+                  <a:schemeClr val="accent1"/>
+                </a:solidFill>
+                <a:latin typeface="Arial" pitchFamily="34" charset="0"/>
+                <a:ea typeface="Arial" pitchFamily="34" charset="-122"/>
+                <a:cs typeface="Arial" pitchFamily="34" charset="-120"/>
+              </a:rPr>
+              <a:t>2 → 6</a:t>
+            </a:r>
+            <a:endParaRPr lang="en-US" sz="3200" dirty="0"/>
+          </a:p>
+        </p:txBody>
+      </p:sp>
+      <p:sp>
+        <p:nvSpPr>
+          <p:cNvPr id="10" name="stat label backend pods via HPA at 60% CPU"/>
+          <p:cNvSpPr txBox="1"/>
+          <p:nvPr/>
+        </p:nvSpPr>
+        <p:spPr>
+          <a:xfrm>
+            <a:off x="7086600" y="1618488"/>
+            <a:ext cx="1645920" cy="457200"/>
+          </a:xfrm>
+          <a:prstGeom prst="rect">
+            <a:avLst/>
+          </a:prstGeom>
+          <a:noFill/>
+          <a:ln/>
+        </p:spPr>
+        <p:txBody>
+          <a:bodyPr wrap="square" lIns="0" tIns="0" rIns="0" bIns="0" rtlCol="0" anchor="t"/>
+          <a:lstStyle/>
+          <a:p>
+            <a:pPr indent="0" marL="0">
+              <a:buNone/>
+            </a:pPr>
+            <a:r>
+              <a:rPr lang="en-US" sz="1300" dirty="0">
+                <a:solidFill>
+                  <a:schemeClr val="tx1"/>
+                </a:solidFill>
+              </a:rPr>
+              <a:t>backend pods via HPA at 60% CPU</a:t>
+            </a:r>
+            <a:endParaRPr lang="en-US" sz="1300" dirty="0"/>
+          </a:p>
+        </p:txBody>
+      </p:sp>
+      <p:sp>
+        <p:nvSpPr>
+          <p:cNvPr id="11" name="stat 5xx error ratio"/>
+          <p:cNvSpPr txBox="1"/>
+          <p:nvPr/>
+        </p:nvSpPr>
+        <p:spPr>
+          <a:xfrm>
+            <a:off x="5257800" y="2331720"/>
+            <a:ext cx="1645920" cy="566928"/>
+          </a:xfrm>
+          <a:prstGeom prst="rect">
+            <a:avLst/>
+          </a:prstGeom>
+          <a:noFill/>
+          <a:ln/>
+        </p:spPr>
+        <p:txBody>
+          <a:bodyPr wrap="square" lIns="0" tIns="0" rIns="0" bIns="0" rtlCol="0" anchor="ctr"/>
+          <a:lstStyle/>
+          <a:p>
+            <a:pPr indent="0" marL="0">
+              <a:buNone/>
+            </a:pPr>
+            <a:r>
+              <a:rPr lang="en-US" sz="3200" b="1" dirty="0">
+                <a:solidFill>
+                  <a:schemeClr val="accent1"/>
+                </a:solidFill>
+                <a:latin typeface="Arial" pitchFamily="34" charset="0"/>
+                <a:ea typeface="Arial" pitchFamily="34" charset="-122"/>
+                <a:cs typeface="Arial" pitchFamily="34" charset="-120"/>
+              </a:rPr>
+              <a:t>0 %</a:t>
+            </a:r>
+            <a:endParaRPr lang="en-US" sz="3200" dirty="0"/>
+          </a:p>
+        </p:txBody>
+      </p:sp>
+      <p:sp>
+        <p:nvSpPr>
+          <p:cNvPr id="12" name="stat label 5xx error ratio"/>
+          <p:cNvSpPr txBox="1"/>
+          <p:nvPr/>
+        </p:nvSpPr>
+        <p:spPr>
+          <a:xfrm>
+            <a:off x="5257800" y="2898648"/>
+            <a:ext cx="1645920" cy="457200"/>
+          </a:xfrm>
+          <a:prstGeom prst="rect">
+            <a:avLst/>
+          </a:prstGeom>
+          <a:noFill/>
+          <a:ln/>
+        </p:spPr>
+        <p:txBody>
+          <a:bodyPr wrap="square" lIns="0" tIns="0" rIns="0" bIns="0" rtlCol="0" anchor="t"/>
+          <a:lstStyle/>
+          <a:p>
+            <a:pPr indent="0" marL="0">
+              <a:buNone/>
+            </a:pPr>
+            <a:r>
+              <a:rPr lang="en-US" sz="1300" dirty="0">
+                <a:solidFill>
+                  <a:schemeClr val="tx1"/>
+                </a:solidFill>
+              </a:rPr>
+              <a:t>5xx error ratio</a:t>
+            </a:r>
+            <a:endParaRPr lang="en-US" sz="1300" dirty="0"/>
+          </a:p>
+        </p:txBody>
+      </p:sp>
+      <p:sp>
+        <p:nvSpPr>
+          <p:cNvPr id="13" name="stat p95 latency under load"/>
+          <p:cNvSpPr txBox="1"/>
+          <p:nvPr/>
+        </p:nvSpPr>
+        <p:spPr>
+          <a:xfrm>
+            <a:off x="7086600" y="2331720"/>
+            <a:ext cx="1645920" cy="566928"/>
+          </a:xfrm>
+          <a:prstGeom prst="rect">
+            <a:avLst/>
+          </a:prstGeom>
+          <a:noFill/>
+          <a:ln/>
+        </p:spPr>
+        <p:txBody>
+          <a:bodyPr wrap="square" lIns="0" tIns="0" rIns="0" bIns="0" rtlCol="0" anchor="ctr"/>
+          <a:lstStyle/>
+          <a:p>
+            <a:pPr indent="0" marL="0">
+              <a:buNone/>
+            </a:pPr>
+            <a:r>
+              <a:rPr lang="en-US" sz="3200" b="1" dirty="0">
+                <a:solidFill>
+                  <a:schemeClr val="accent1"/>
+                </a:solidFill>
+                <a:latin typeface="Arial" pitchFamily="34" charset="0"/>
+                <a:ea typeface="Arial" pitchFamily="34" charset="-122"/>
+                <a:cs typeface="Arial" pitchFamily="34" charset="-120"/>
+              </a:rPr>
+              <a:t>95 ms</a:t>
+            </a:r>
+            <a:endParaRPr lang="en-US" sz="3200" dirty="0"/>
+          </a:p>
+        </p:txBody>
+      </p:sp>
+      <p:sp>
+        <p:nvSpPr>
+          <p:cNvPr id="14" name="stat label p95 latency under load"/>
+          <p:cNvSpPr txBox="1"/>
+          <p:nvPr/>
+        </p:nvSpPr>
+        <p:spPr>
+          <a:xfrm>
+            <a:off x="7086600" y="2898648"/>
+            <a:ext cx="1645920" cy="457200"/>
+          </a:xfrm>
+          <a:prstGeom prst="rect">
+            <a:avLst/>
+          </a:prstGeom>
+          <a:noFill/>
+          <a:ln/>
+        </p:spPr>
+        <p:txBody>
+          <a:bodyPr wrap="square" lIns="0" tIns="0" rIns="0" bIns="0" rtlCol="0" anchor="t"/>
+          <a:lstStyle/>
+          <a:p>
+            <a:pPr indent="0" marL="0">
+              <a:buNone/>
+            </a:pPr>
+            <a:r>
+              <a:rPr lang="en-US" sz="1300" dirty="0">
+                <a:solidFill>
+                  <a:schemeClr val="tx1"/>
+                </a:solidFill>
+              </a:rPr>
+              <a:t>p95 latency under load</a:t>
+            </a:r>
+            <a:endParaRPr lang="en-US" sz="1300" dirty="0"/>
+          </a:p>
+        </p:txBody>
+      </p:sp>
+      <p:sp>
+        <p:nvSpPr>
+          <p:cNvPr id="15" name="Prometheus targets UP frame"/>
           <p:cNvSpPr/>
           <p:nvPr/>
         </p:nvSpPr>
         <p:spPr>
           <a:xfrm>
-            <a:off x="640080" y="1252728"/>
-            <a:ext cx="384048" cy="384048"/>
-          </a:xfrm>
-          <a:prstGeom prst="ellipse">
-            <a:avLst/>
-          </a:prstGeom>
-          <a:solidFill>
-            <a:schemeClr val="accent2"/>
-          </a:solidFill>
-          <a:ln/>
-        </p:spPr>
-      </p:sp>
-      <p:sp>
-        <p:nvSpPr>
-          <p:cNvPr id="7" name="challenge 1 number"/>
-          <p:cNvSpPr txBox="1"/>
-          <p:nvPr/>
-        </p:nvSpPr>
-        <p:spPr>
-          <a:xfrm>
-            <a:off x="640080" y="1252728"/>
-            <a:ext cx="384048" cy="384048"/>
-          </a:xfrm>
-          <a:prstGeom prst="rect">
-            <a:avLst/>
-          </a:prstGeom>
-          <a:noFill/>
-          <a:ln/>
-        </p:spPr>
-        <p:txBody>
-          <a:bodyPr wrap="square" lIns="0" tIns="0" rIns="0" bIns="0" rtlCol="0" anchor="ctr"/>
-          <a:lstStyle/>
-          <a:p>
-            <a:pPr algn="ctr" indent="0" marL="0">
-              <a:buNone/>
-            </a:pPr>
-            <a:r>
-              <a:rPr lang="en-US" sz="1300" b="1" dirty="0">
-                <a:solidFill>
-                  <a:schemeClr val="tx1"/>
-                </a:solidFill>
-              </a:rPr>
-              <a:t>1</a:t>
-            </a:r>
-            <a:endParaRPr lang="en-US" sz="1300" dirty="0"/>
-          </a:p>
-        </p:txBody>
-      </p:sp>
-      <p:sp>
-        <p:nvSpPr>
-          <p:cNvPr id="8" name="challenge 1 title"/>
-          <p:cNvSpPr txBox="1"/>
-          <p:nvPr/>
-        </p:nvSpPr>
-        <p:spPr>
-          <a:xfrm>
-            <a:off x="1170432" y="1234440"/>
-            <a:ext cx="3108960" cy="420624"/>
-          </a:xfrm>
-          <a:prstGeom prst="rect">
-            <a:avLst/>
-          </a:prstGeom>
-          <a:noFill/>
-          <a:ln/>
-        </p:spPr>
-        <p:txBody>
-          <a:bodyPr wrap="square" lIns="0" tIns="0" rIns="0" bIns="0" rtlCol="0" anchor="ctr"/>
-          <a:lstStyle/>
-          <a:p>
-            <a:pPr indent="0" marL="0">
-              <a:buNone/>
-            </a:pPr>
-            <a:r>
-              <a:rPr lang="en-US" sz="1500" b="1" dirty="0">
-                <a:solidFill>
-                  <a:schemeClr val="tx2"/>
-                </a:solidFill>
-              </a:rPr>
-              <a:t>AWS account never activated</a:t>
-            </a:r>
-            <a:endParaRPr lang="en-US" sz="1500" dirty="0"/>
-          </a:p>
-        </p:txBody>
-      </p:sp>
-      <p:sp>
-        <p:nvSpPr>
-          <p:cNvPr id="9" name="challenge 1 text"/>
-          <p:cNvSpPr txBox="1"/>
-          <p:nvPr/>
-        </p:nvSpPr>
-        <p:spPr>
-          <a:xfrm>
-            <a:off x="640080" y="1801368"/>
-            <a:ext cx="3657600" cy="777240"/>
-          </a:xfrm>
-          <a:prstGeom prst="rect">
-            <a:avLst/>
-          </a:prstGeom>
-          <a:noFill/>
-          <a:ln/>
-        </p:spPr>
-        <p:txBody>
-          <a:bodyPr wrap="square" lIns="0" tIns="0" rIns="0" bIns="0" rtlCol="0" anchor="t"/>
-          <a:lstStyle/>
-          <a:p>
-            <a:pPr indent="0" marL="0">
-              <a:buNone/>
-            </a:pPr>
-            <a:r>
-              <a:rPr lang="en-US" sz="1300" dirty="0">
-                <a:solidFill>
-                  <a:schemeClr val="tx1"/>
-                </a:solidFill>
-              </a:rPr>
-              <a:t>Health showed "customer verification failed". Opened a new account and verified it properly.</a:t>
-            </a:r>
-            <a:endParaRPr lang="en-US" sz="1300" dirty="0"/>
-          </a:p>
-        </p:txBody>
-      </p:sp>
-      <p:sp>
-        <p:nvSpPr>
-          <p:cNvPr id="10" name="challenge 2 card"/>
-          <p:cNvSpPr/>
-          <p:nvPr/>
-        </p:nvSpPr>
-        <p:spPr>
-          <a:xfrm>
-            <a:off x="4663440" y="1051560"/>
-            <a:ext cx="4023360" cy="1645920"/>
+            <a:off x="2022653" y="3749040"/>
+            <a:ext cx="5098694" cy="960120"/>
           </a:xfrm>
           <a:prstGeom prst="roundRect">
             <a:avLst>
-              <a:gd name="adj" fmla="val 4444"/>
+              <a:gd name="adj" fmla="val 5714"/>
             </a:avLst>
           </a:prstGeom>
           <a:solidFill>
-            <a:schemeClr val="bg2"/>
+            <a:srgbClr val="FFFFFF"/>
           </a:solidFill>
-          <a:ln/>
-        </p:spPr>
-      </p:sp>
-      <p:sp>
-        <p:nvSpPr>
-          <p:cNvPr id="11" name="challenge 2 chip"/>
-          <p:cNvSpPr/>
-          <p:nvPr/>
-        </p:nvSpPr>
-        <p:spPr>
-          <a:xfrm>
-            <a:off x="4846320" y="1252728"/>
-            <a:ext cx="384048" cy="384048"/>
-          </a:xfrm>
-          <a:prstGeom prst="ellipse">
-            <a:avLst/>
-          </a:prstGeom>
-          <a:solidFill>
-            <a:schemeClr val="accent2"/>
-          </a:solidFill>
-          <a:ln/>
-        </p:spPr>
-      </p:sp>
-      <p:sp>
-        <p:nvSpPr>
-          <p:cNvPr id="12" name="challenge 2 number"/>
-          <p:cNvSpPr txBox="1"/>
-          <p:nvPr/>
-        </p:nvSpPr>
-        <p:spPr>
-          <a:xfrm>
-            <a:off x="4846320" y="1252728"/>
-            <a:ext cx="384048" cy="384048"/>
-          </a:xfrm>
-          <a:prstGeom prst="rect">
-            <a:avLst/>
-          </a:prstGeom>
-          <a:noFill/>
-          <a:ln/>
-        </p:spPr>
-        <p:txBody>
-          <a:bodyPr wrap="square" lIns="0" tIns="0" rIns="0" bIns="0" rtlCol="0" anchor="ctr"/>
-          <a:lstStyle/>
-          <a:p>
-            <a:pPr algn="ctr" indent="0" marL="0">
-              <a:buNone/>
-            </a:pPr>
-            <a:r>
-              <a:rPr lang="en-US" sz="1300" b="1" dirty="0">
-                <a:solidFill>
-                  <a:schemeClr val="tx1"/>
-                </a:solidFill>
-              </a:rPr>
-              <a:t>2</a:t>
-            </a:r>
-            <a:endParaRPr lang="en-US" sz="1300" dirty="0"/>
-          </a:p>
-        </p:txBody>
-      </p:sp>
-      <p:sp>
-        <p:nvSpPr>
-          <p:cNvPr id="13" name="challenge 2 title"/>
-          <p:cNvSpPr txBox="1"/>
-          <p:nvPr/>
-        </p:nvSpPr>
-        <p:spPr>
-          <a:xfrm>
-            <a:off x="5376672" y="1234440"/>
-            <a:ext cx="3108960" cy="420624"/>
-          </a:xfrm>
-          <a:prstGeom prst="rect">
-            <a:avLst/>
-          </a:prstGeom>
-          <a:noFill/>
-          <a:ln/>
-        </p:spPr>
-        <p:txBody>
-          <a:bodyPr wrap="square" lIns="0" tIns="0" rIns="0" bIns="0" rtlCol="0" anchor="ctr"/>
-          <a:lstStyle/>
-          <a:p>
-            <a:pPr indent="0" marL="0">
-              <a:buNone/>
-            </a:pPr>
-            <a:r>
-              <a:rPr lang="en-US" sz="1500" b="1" dirty="0">
-                <a:solidFill>
-                  <a:schemeClr val="tx2"/>
-                </a:solidFill>
-              </a:rPr>
-              <a:t>Free plan blocked t3.medium</a:t>
-            </a:r>
-            <a:endParaRPr lang="en-US" sz="1500" dirty="0"/>
-          </a:p>
-        </p:txBody>
-      </p:sp>
-      <p:sp>
-        <p:nvSpPr>
-          <p:cNvPr id="14" name="challenge 2 text"/>
-          <p:cNvSpPr txBox="1"/>
-          <p:nvPr/>
-        </p:nvSpPr>
-        <p:spPr>
-          <a:xfrm>
-            <a:off x="4846320" y="1801368"/>
-            <a:ext cx="3657600" cy="777240"/>
-          </a:xfrm>
-          <a:prstGeom prst="rect">
-            <a:avLst/>
-          </a:prstGeom>
-          <a:noFill/>
-          <a:ln/>
-        </p:spPr>
-        <p:txBody>
-          <a:bodyPr wrap="square" lIns="0" tIns="0" rIns="0" bIns="0" rtlCol="0" anchor="t"/>
-          <a:lstStyle/>
-          <a:p>
-            <a:pPr indent="0" marL="0">
-              <a:buNone/>
-            </a:pPr>
-            <a:r>
-              <a:rPr lang="en-US" sz="1300" dirty="0">
-                <a:solidFill>
-                  <a:schemeClr val="tx1"/>
-                </a:solidFill>
-              </a:rPr>
-              <a:t>EC2 only allows free-tier types → nodes moved to m7i-flex.large (8 GiB).</a:t>
-            </a:r>
-            <a:endParaRPr lang="en-US" sz="1300" dirty="0"/>
-          </a:p>
-        </p:txBody>
-      </p:sp>
-      <p:sp>
-        <p:nvSpPr>
-          <p:cNvPr id="15" name="challenge 3 card"/>
-          <p:cNvSpPr/>
-          <p:nvPr/>
-        </p:nvSpPr>
-        <p:spPr>
-          <a:xfrm>
-            <a:off x="457200" y="2862072"/>
-            <a:ext cx="4023360" cy="1645920"/>
-          </a:xfrm>
-          <a:prstGeom prst="roundRect">
-            <a:avLst>
-              <a:gd name="adj" fmla="val 4444"/>
-            </a:avLst>
-          </a:prstGeom>
-          <a:solidFill>
-            <a:schemeClr val="bg2"/>
-          </a:solidFill>
-          <a:ln/>
-        </p:spPr>
-      </p:sp>
-      <p:sp>
-        <p:nvSpPr>
-          <p:cNvPr id="16" name="challenge 3 chip"/>
-          <p:cNvSpPr/>
-          <p:nvPr/>
-        </p:nvSpPr>
-        <p:spPr>
-          <a:xfrm>
-            <a:off x="640080" y="3063240"/>
-            <a:ext cx="384048" cy="384048"/>
-          </a:xfrm>
-          <a:prstGeom prst="ellipse">
-            <a:avLst/>
-          </a:prstGeom>
-          <a:solidFill>
-            <a:schemeClr val="accent2"/>
-          </a:solidFill>
-          <a:ln/>
-        </p:spPr>
-      </p:sp>
-      <p:sp>
-        <p:nvSpPr>
-          <p:cNvPr id="17" name="challenge 3 number"/>
-          <p:cNvSpPr txBox="1"/>
-          <p:nvPr/>
-        </p:nvSpPr>
-        <p:spPr>
-          <a:xfrm>
-            <a:off x="640080" y="3063240"/>
-            <a:ext cx="384048" cy="384048"/>
-          </a:xfrm>
-          <a:prstGeom prst="rect">
-            <a:avLst/>
-          </a:prstGeom>
-          <a:noFill/>
-          <a:ln/>
-        </p:spPr>
-        <p:txBody>
-          <a:bodyPr wrap="square" lIns="0" tIns="0" rIns="0" bIns="0" rtlCol="0" anchor="ctr"/>
-          <a:lstStyle/>
-          <a:p>
-            <a:pPr algn="ctr" indent="0" marL="0">
-              <a:buNone/>
-            </a:pPr>
-            <a:r>
-              <a:rPr lang="en-US" sz="1300" b="1" dirty="0">
-                <a:solidFill>
-                  <a:schemeClr val="tx1"/>
-                </a:solidFill>
-              </a:rPr>
-              <a:t>3</a:t>
-            </a:r>
-            <a:endParaRPr lang="en-US" sz="1300" dirty="0"/>
-          </a:p>
-        </p:txBody>
-      </p:sp>
-      <p:sp>
-        <p:nvSpPr>
-          <p:cNvPr id="18" name="challenge 3 title"/>
-          <p:cNvSpPr txBox="1"/>
-          <p:nvPr/>
-        </p:nvSpPr>
-        <p:spPr>
-          <a:xfrm>
-            <a:off x="1170432" y="3044952"/>
-            <a:ext cx="3108960" cy="420624"/>
-          </a:xfrm>
-          <a:prstGeom prst="rect">
-            <a:avLst/>
-          </a:prstGeom>
-          <a:noFill/>
-          <a:ln/>
-        </p:spPr>
-        <p:txBody>
-          <a:bodyPr wrap="square" lIns="0" tIns="0" rIns="0" bIns="0" rtlCol="0" anchor="ctr"/>
-          <a:lstStyle/>
-          <a:p>
-            <a:pPr indent="0" marL="0">
-              <a:buNone/>
-            </a:pPr>
-            <a:r>
-              <a:rPr lang="en-US" sz="1500" b="1" dirty="0">
-                <a:solidFill>
-                  <a:schemeClr val="tx2"/>
-                </a:solidFill>
-              </a:rPr>
-              <a:t>CI could not assume AWS role</a:t>
-            </a:r>
-            <a:endParaRPr lang="en-US" sz="1500" dirty="0"/>
-          </a:p>
-        </p:txBody>
-      </p:sp>
-      <p:sp>
-        <p:nvSpPr>
-          <p:cNvPr id="19" name="challenge 3 text"/>
-          <p:cNvSpPr txBox="1"/>
-          <p:nvPr/>
-        </p:nvSpPr>
-        <p:spPr>
-          <a:xfrm>
-            <a:off x="640080" y="3611880"/>
-            <a:ext cx="3657600" cy="777240"/>
-          </a:xfrm>
-          <a:prstGeom prst="rect">
-            <a:avLst/>
-          </a:prstGeom>
-          <a:noFill/>
-          <a:ln/>
-        </p:spPr>
-        <p:txBody>
-          <a:bodyPr wrap="square" lIns="0" tIns="0" rIns="0" bIns="0" rtlCol="0" anchor="t"/>
-          <a:lstStyle/>
-          <a:p>
-            <a:pPr indent="0" marL="0">
-              <a:buNone/>
-            </a:pPr>
-            <a:r>
-              <a:rPr lang="en-US" sz="1300" dirty="0">
-                <a:solidFill>
-                  <a:schemeClr val="tx1"/>
-                </a:solidFill>
-              </a:rPr>
-              <a:t>GitHub sends an immutable OIDC subject → trust policy accepts it, set in Terraform.</a:t>
-            </a:r>
-            <a:endParaRPr lang="en-US" sz="1300" dirty="0"/>
-          </a:p>
-        </p:txBody>
-      </p:sp>
-      <p:sp>
-        <p:nvSpPr>
-          <p:cNvPr id="20" name="challenge 4 card"/>
-          <p:cNvSpPr/>
-          <p:nvPr/>
-        </p:nvSpPr>
-        <p:spPr>
-          <a:xfrm>
-            <a:off x="4663440" y="2862072"/>
-            <a:ext cx="4023360" cy="1645920"/>
-          </a:xfrm>
-          <a:prstGeom prst="roundRect">
-            <a:avLst>
-              <a:gd name="adj" fmla="val 4444"/>
-            </a:avLst>
-          </a:prstGeom>
-          <a:solidFill>
-            <a:schemeClr val="bg2"/>
-          </a:solidFill>
-          <a:ln/>
-        </p:spPr>
-      </p:sp>
-      <p:sp>
-        <p:nvSpPr>
-          <p:cNvPr id="21" name="challenge 4 chip"/>
-          <p:cNvSpPr/>
-          <p:nvPr/>
-        </p:nvSpPr>
-        <p:spPr>
-          <a:xfrm>
-            <a:off x="4846320" y="3063240"/>
-            <a:ext cx="384048" cy="384048"/>
-          </a:xfrm>
-          <a:prstGeom prst="ellipse">
-            <a:avLst/>
-          </a:prstGeom>
-          <a:solidFill>
-            <a:schemeClr val="accent2"/>
-          </a:solidFill>
-          <a:ln/>
-        </p:spPr>
-      </p:sp>
-      <p:sp>
-        <p:nvSpPr>
-          <p:cNvPr id="22" name="challenge 4 number"/>
-          <p:cNvSpPr txBox="1"/>
-          <p:nvPr/>
-        </p:nvSpPr>
-        <p:spPr>
-          <a:xfrm>
-            <a:off x="4846320" y="3063240"/>
-            <a:ext cx="384048" cy="384048"/>
-          </a:xfrm>
-          <a:prstGeom prst="rect">
-            <a:avLst/>
-          </a:prstGeom>
-          <a:noFill/>
-          <a:ln/>
-        </p:spPr>
-        <p:txBody>
-          <a:bodyPr wrap="square" lIns="0" tIns="0" rIns="0" bIns="0" rtlCol="0" anchor="ctr"/>
-          <a:lstStyle/>
-          <a:p>
-            <a:pPr algn="ctr" indent="0" marL="0">
-              <a:buNone/>
-            </a:pPr>
-            <a:r>
-              <a:rPr lang="en-US" sz="1300" b="1" dirty="0">
-                <a:solidFill>
-                  <a:schemeClr val="tx1"/>
-                </a:solidFill>
-              </a:rPr>
-              <a:t>4</a:t>
-            </a:r>
-            <a:endParaRPr lang="en-US" sz="1300" dirty="0"/>
-          </a:p>
-        </p:txBody>
-      </p:sp>
-      <p:sp>
-        <p:nvSpPr>
-          <p:cNvPr id="23" name="challenge 4 title"/>
-          <p:cNvSpPr txBox="1"/>
-          <p:nvPr/>
-        </p:nvSpPr>
-        <p:spPr>
-          <a:xfrm>
-            <a:off x="5376672" y="3044952"/>
-            <a:ext cx="3108960" cy="420624"/>
-          </a:xfrm>
-          <a:prstGeom prst="rect">
-            <a:avLst/>
-          </a:prstGeom>
-          <a:noFill/>
-          <a:ln/>
-        </p:spPr>
-        <p:txBody>
-          <a:bodyPr wrap="square" lIns="0" tIns="0" rIns="0" bIns="0" rtlCol="0" anchor="ctr"/>
-          <a:lstStyle/>
-          <a:p>
-            <a:pPr indent="0" marL="0">
-              <a:buNone/>
-            </a:pPr>
-            <a:r>
-              <a:rPr lang="en-US" sz="1500" b="1" dirty="0">
-                <a:solidFill>
-                  <a:schemeClr val="tx2"/>
-                </a:solidFill>
-              </a:rPr>
-              <a:t>Helm denied the ServiceMonitor</a:t>
-            </a:r>
-            <a:endParaRPr lang="en-US" sz="1500" dirty="0"/>
-          </a:p>
-        </p:txBody>
-      </p:sp>
-      <p:sp>
-        <p:nvSpPr>
-          <p:cNvPr id="24" name="challenge 4 text"/>
-          <p:cNvSpPr txBox="1"/>
-          <p:nvPr/>
-        </p:nvSpPr>
-        <p:spPr>
-          <a:xfrm>
-            <a:off x="4846320" y="3611880"/>
-            <a:ext cx="3657600" cy="777240"/>
-          </a:xfrm>
-          <a:prstGeom prst="rect">
-            <a:avLst/>
-          </a:prstGeom>
-          <a:noFill/>
-          <a:ln/>
-        </p:spPr>
-        <p:txBody>
-          <a:bodyPr wrap="square" lIns="0" tIns="0" rIns="0" bIns="0" rtlCol="0" anchor="t"/>
-          <a:lstStyle/>
-          <a:p>
-            <a:pPr indent="0" marL="0">
-              <a:buNone/>
-            </a:pPr>
-            <a:r>
-              <a:rPr lang="en-US" sz="1300" dirty="0">
-                <a:solidFill>
-                  <a:schemeClr val="tx1"/>
-                </a:solidFill>
-              </a:rPr>
-              <a:t>EKS namespace-admin skips CRDs → small RBAC Role, still least privilege.</a:t>
-            </a:r>
-            <a:endParaRPr lang="en-US" sz="1300" dirty="0"/>
-          </a:p>
-        </p:txBody>
-      </p:sp>
+          <a:ln w="9525">
+            <a:solidFill>
+              <a:srgbClr val="D5DEDD"/>
+            </a:solidFill>
+            <a:prstDash val="solid"/>
+          </a:ln>
+          <a:effectLst>
+            <a:outerShdw sx="100000" sy="100000" kx="0" ky="0" algn="bl" rotWithShape="0" blurRad="76200" dist="25400" dir="5400000">
+              <a:srgbClr val="000000">
+                <a:alpha val="18000"/>
+              </a:srgbClr>
+            </a:outerShdw>
+          </a:effectLst>
+        </p:spPr>
+      </p:sp>
+      <p:pic>
+        <p:nvPicPr>
+          <p:cNvPr id="16" name="Prometheus targets UP" descr="Prometheus targets UP">    </p:cNvPr>
+          <p:cNvPicPr>
+            <a:picLocks noChangeAspect="1"/>
+          </p:cNvPicPr>
+          <p:nvPr/>
+        </p:nvPicPr>
+        <p:blipFill>
+          <a:blip r:embed="rId2"/>
+          <a:stretch>
+            <a:fillRect/>
+          </a:stretch>
+        </p:blipFill>
+        <p:spPr>
+          <a:xfrm>
+            <a:off x="2077517" y="3803904"/>
+            <a:ext cx="4988966" cy="850392"/>
+          </a:xfrm>
+          <a:prstGeom prst="rect">
+            <a:avLst/>
+          </a:prstGeom>
+        </p:spPr>
+      </p:pic>
       <p:sp>
         <p:nvSpPr>
           <p:cNvPr id="25" name="Slide Number Placeholder 0"/>
@@ -4775,6 +4539,770 @@
       </p:grpSpPr>
       <p:sp>
         <p:nvSpPr>
+          <p:cNvPr id="2" name="Text 1"/>
+          <p:cNvSpPr/>
+          <p:nvPr>
+            <p:ph idx="101" type="title" hasCustomPrompt="1"/>
+          </p:nvPr>
+        </p:nvSpPr>
+        <p:spPr>
+          <a:xfrm>
+            <a:off x="1024128" y="274320"/>
+            <a:ext cx="7680960" cy="566928"/>
+          </a:xfrm>
+          <a:prstGeom prst="rect">
+            <a:avLst/>
+          </a:prstGeom>
+          <a:noFill/>
+          <a:ln/>
+        </p:spPr>
+        <p:txBody>
+          <a:bodyPr wrap="square" lIns="0" tIns="0" rIns="0" bIns="0" rtlCol="0" anchor="ctr"/>
+          <a:lstStyle/>
+          <a:p>
+            <a:pPr algn="l" indent="0" marL="0">
+              <a:buNone/>
+            </a:pPr>
+            <a:r>
+              <a:rPr lang="en-US" sz="2800" b="1" dirty="0">
+                <a:solidFill>
+                  <a:schemeClr val="tx2"/>
+                </a:solidFill>
+              </a:rPr>
+              <a:t>Real problems I solved</a:t>
+            </a:r>
+            <a:endParaRPr lang="en-US" sz="2800" dirty="0"/>
+          </a:p>
+        </p:txBody>
+      </p:sp>
+      <p:sp>
+        <p:nvSpPr>
+          <p:cNvPr id="3" name="module chip"/>
+          <p:cNvSpPr/>
+          <p:nvPr/>
+        </p:nvSpPr>
+        <p:spPr>
+          <a:xfrm>
+            <a:off x="457200" y="329184"/>
+            <a:ext cx="457200" cy="457200"/>
+          </a:xfrm>
+          <a:prstGeom prst="ellipse">
+            <a:avLst/>
+          </a:prstGeom>
+          <a:solidFill>
+            <a:schemeClr val="accent1"/>
+          </a:solidFill>
+          <a:ln/>
+        </p:spPr>
+      </p:sp>
+      <p:sp>
+        <p:nvSpPr>
+          <p:cNvPr id="4" name="module chip label"/>
+          <p:cNvSpPr txBox="1"/>
+          <p:nvPr/>
+        </p:nvSpPr>
+        <p:spPr>
+          <a:xfrm>
+            <a:off x="457200" y="329184"/>
+            <a:ext cx="457200" cy="457200"/>
+          </a:xfrm>
+          <a:prstGeom prst="rect">
+            <a:avLst/>
+          </a:prstGeom>
+          <a:noFill/>
+          <a:ln/>
+        </p:spPr>
+        <p:txBody>
+          <a:bodyPr wrap="square" lIns="0" tIns="0" rIns="0" bIns="0" rtlCol="0" anchor="ctr"/>
+          <a:lstStyle/>
+          <a:p>
+            <a:pPr algn="ctr" indent="0" marL="0">
+              <a:buNone/>
+            </a:pPr>
+            <a:r>
+              <a:rPr lang="en-US" sz="1200" b="1" dirty="0">
+                <a:solidFill>
+                  <a:schemeClr val="bg1"/>
+                </a:solidFill>
+              </a:rPr>
+              <a:t>!</a:t>
+            </a:r>
+            <a:endParaRPr lang="en-US" sz="1200" dirty="0"/>
+          </a:p>
+        </p:txBody>
+      </p:sp>
+      <p:sp>
+        <p:nvSpPr>
+          <p:cNvPr id="5" name="challenge 1 card"/>
+          <p:cNvSpPr/>
+          <p:nvPr/>
+        </p:nvSpPr>
+        <p:spPr>
+          <a:xfrm>
+            <a:off x="457200" y="1051560"/>
+            <a:ext cx="4023360" cy="1645920"/>
+          </a:xfrm>
+          <a:prstGeom prst="roundRect">
+            <a:avLst>
+              <a:gd name="adj" fmla="val 4444"/>
+            </a:avLst>
+          </a:prstGeom>
+          <a:solidFill>
+            <a:schemeClr val="bg2"/>
+          </a:solidFill>
+          <a:ln/>
+        </p:spPr>
+      </p:sp>
+      <p:sp>
+        <p:nvSpPr>
+          <p:cNvPr id="6" name="challenge 1 chip"/>
+          <p:cNvSpPr/>
+          <p:nvPr/>
+        </p:nvSpPr>
+        <p:spPr>
+          <a:xfrm>
+            <a:off x="640080" y="1252728"/>
+            <a:ext cx="384048" cy="384048"/>
+          </a:xfrm>
+          <a:prstGeom prst="ellipse">
+            <a:avLst/>
+          </a:prstGeom>
+          <a:solidFill>
+            <a:schemeClr val="accent2"/>
+          </a:solidFill>
+          <a:ln/>
+        </p:spPr>
+      </p:sp>
+      <p:sp>
+        <p:nvSpPr>
+          <p:cNvPr id="7" name="challenge 1 number"/>
+          <p:cNvSpPr txBox="1"/>
+          <p:nvPr/>
+        </p:nvSpPr>
+        <p:spPr>
+          <a:xfrm>
+            <a:off x="640080" y="1252728"/>
+            <a:ext cx="384048" cy="384048"/>
+          </a:xfrm>
+          <a:prstGeom prst="rect">
+            <a:avLst/>
+          </a:prstGeom>
+          <a:noFill/>
+          <a:ln/>
+        </p:spPr>
+        <p:txBody>
+          <a:bodyPr wrap="square" lIns="0" tIns="0" rIns="0" bIns="0" rtlCol="0" anchor="ctr"/>
+          <a:lstStyle/>
+          <a:p>
+            <a:pPr algn="ctr" indent="0" marL="0">
+              <a:buNone/>
+            </a:pPr>
+            <a:r>
+              <a:rPr lang="en-US" sz="1300" b="1" dirty="0">
+                <a:solidFill>
+                  <a:schemeClr val="tx1"/>
+                </a:solidFill>
+              </a:rPr>
+              <a:t>1</a:t>
+            </a:r>
+            <a:endParaRPr lang="en-US" sz="1300" dirty="0"/>
+          </a:p>
+        </p:txBody>
+      </p:sp>
+      <p:sp>
+        <p:nvSpPr>
+          <p:cNvPr id="8" name="challenge 1 title"/>
+          <p:cNvSpPr txBox="1"/>
+          <p:nvPr/>
+        </p:nvSpPr>
+        <p:spPr>
+          <a:xfrm>
+            <a:off x="1170432" y="1234440"/>
+            <a:ext cx="3108960" cy="420624"/>
+          </a:xfrm>
+          <a:prstGeom prst="rect">
+            <a:avLst/>
+          </a:prstGeom>
+          <a:noFill/>
+          <a:ln/>
+        </p:spPr>
+        <p:txBody>
+          <a:bodyPr wrap="square" lIns="0" tIns="0" rIns="0" bIns="0" rtlCol="0" anchor="ctr"/>
+          <a:lstStyle/>
+          <a:p>
+            <a:pPr indent="0" marL="0">
+              <a:buNone/>
+            </a:pPr>
+            <a:r>
+              <a:rPr lang="en-US" sz="1500" b="1" dirty="0">
+                <a:solidFill>
+                  <a:schemeClr val="tx2"/>
+                </a:solidFill>
+              </a:rPr>
+              <a:t>AWS account never activated</a:t>
+            </a:r>
+            <a:endParaRPr lang="en-US" sz="1500" dirty="0"/>
+          </a:p>
+        </p:txBody>
+      </p:sp>
+      <p:sp>
+        <p:nvSpPr>
+          <p:cNvPr id="9" name="challenge 1 text"/>
+          <p:cNvSpPr txBox="1"/>
+          <p:nvPr/>
+        </p:nvSpPr>
+        <p:spPr>
+          <a:xfrm>
+            <a:off x="640080" y="1801368"/>
+            <a:ext cx="3657600" cy="777240"/>
+          </a:xfrm>
+          <a:prstGeom prst="rect">
+            <a:avLst/>
+          </a:prstGeom>
+          <a:noFill/>
+          <a:ln/>
+        </p:spPr>
+        <p:txBody>
+          <a:bodyPr wrap="square" lIns="0" tIns="0" rIns="0" bIns="0" rtlCol="0" anchor="t"/>
+          <a:lstStyle/>
+          <a:p>
+            <a:pPr indent="0" marL="0">
+              <a:buNone/>
+            </a:pPr>
+            <a:r>
+              <a:rPr lang="en-US" sz="1300" dirty="0">
+                <a:solidFill>
+                  <a:schemeClr val="tx1"/>
+                </a:solidFill>
+              </a:rPr>
+              <a:t>Health showed "customer verification failed". Opened a new account and verified it properly.</a:t>
+            </a:r>
+            <a:endParaRPr lang="en-US" sz="1300" dirty="0"/>
+          </a:p>
+        </p:txBody>
+      </p:sp>
+      <p:sp>
+        <p:nvSpPr>
+          <p:cNvPr id="10" name="challenge 2 card"/>
+          <p:cNvSpPr/>
+          <p:nvPr/>
+        </p:nvSpPr>
+        <p:spPr>
+          <a:xfrm>
+            <a:off x="4663440" y="1051560"/>
+            <a:ext cx="4023360" cy="1645920"/>
+          </a:xfrm>
+          <a:prstGeom prst="roundRect">
+            <a:avLst>
+              <a:gd name="adj" fmla="val 4444"/>
+            </a:avLst>
+          </a:prstGeom>
+          <a:solidFill>
+            <a:schemeClr val="bg2"/>
+          </a:solidFill>
+          <a:ln/>
+        </p:spPr>
+      </p:sp>
+      <p:sp>
+        <p:nvSpPr>
+          <p:cNvPr id="11" name="challenge 2 chip"/>
+          <p:cNvSpPr/>
+          <p:nvPr/>
+        </p:nvSpPr>
+        <p:spPr>
+          <a:xfrm>
+            <a:off x="4846320" y="1252728"/>
+            <a:ext cx="384048" cy="384048"/>
+          </a:xfrm>
+          <a:prstGeom prst="ellipse">
+            <a:avLst/>
+          </a:prstGeom>
+          <a:solidFill>
+            <a:schemeClr val="accent2"/>
+          </a:solidFill>
+          <a:ln/>
+        </p:spPr>
+      </p:sp>
+      <p:sp>
+        <p:nvSpPr>
+          <p:cNvPr id="12" name="challenge 2 number"/>
+          <p:cNvSpPr txBox="1"/>
+          <p:nvPr/>
+        </p:nvSpPr>
+        <p:spPr>
+          <a:xfrm>
+            <a:off x="4846320" y="1252728"/>
+            <a:ext cx="384048" cy="384048"/>
+          </a:xfrm>
+          <a:prstGeom prst="rect">
+            <a:avLst/>
+          </a:prstGeom>
+          <a:noFill/>
+          <a:ln/>
+        </p:spPr>
+        <p:txBody>
+          <a:bodyPr wrap="square" lIns="0" tIns="0" rIns="0" bIns="0" rtlCol="0" anchor="ctr"/>
+          <a:lstStyle/>
+          <a:p>
+            <a:pPr algn="ctr" indent="0" marL="0">
+              <a:buNone/>
+            </a:pPr>
+            <a:r>
+              <a:rPr lang="en-US" sz="1300" b="1" dirty="0">
+                <a:solidFill>
+                  <a:schemeClr val="tx1"/>
+                </a:solidFill>
+              </a:rPr>
+              <a:t>2</a:t>
+            </a:r>
+            <a:endParaRPr lang="en-US" sz="1300" dirty="0"/>
+          </a:p>
+        </p:txBody>
+      </p:sp>
+      <p:sp>
+        <p:nvSpPr>
+          <p:cNvPr id="13" name="challenge 2 title"/>
+          <p:cNvSpPr txBox="1"/>
+          <p:nvPr/>
+        </p:nvSpPr>
+        <p:spPr>
+          <a:xfrm>
+            <a:off x="5376672" y="1234440"/>
+            <a:ext cx="3108960" cy="420624"/>
+          </a:xfrm>
+          <a:prstGeom prst="rect">
+            <a:avLst/>
+          </a:prstGeom>
+          <a:noFill/>
+          <a:ln/>
+        </p:spPr>
+        <p:txBody>
+          <a:bodyPr wrap="square" lIns="0" tIns="0" rIns="0" bIns="0" rtlCol="0" anchor="ctr"/>
+          <a:lstStyle/>
+          <a:p>
+            <a:pPr indent="0" marL="0">
+              <a:buNone/>
+            </a:pPr>
+            <a:r>
+              <a:rPr lang="en-US" sz="1500" b="1" dirty="0">
+                <a:solidFill>
+                  <a:schemeClr val="tx2"/>
+                </a:solidFill>
+              </a:rPr>
+              <a:t>Free plan blocked t3.medium</a:t>
+            </a:r>
+            <a:endParaRPr lang="en-US" sz="1500" dirty="0"/>
+          </a:p>
+        </p:txBody>
+      </p:sp>
+      <p:sp>
+        <p:nvSpPr>
+          <p:cNvPr id="14" name="challenge 2 text"/>
+          <p:cNvSpPr txBox="1"/>
+          <p:nvPr/>
+        </p:nvSpPr>
+        <p:spPr>
+          <a:xfrm>
+            <a:off x="4846320" y="1801368"/>
+            <a:ext cx="3657600" cy="777240"/>
+          </a:xfrm>
+          <a:prstGeom prst="rect">
+            <a:avLst/>
+          </a:prstGeom>
+          <a:noFill/>
+          <a:ln/>
+        </p:spPr>
+        <p:txBody>
+          <a:bodyPr wrap="square" lIns="0" tIns="0" rIns="0" bIns="0" rtlCol="0" anchor="t"/>
+          <a:lstStyle/>
+          <a:p>
+            <a:pPr indent="0" marL="0">
+              <a:buNone/>
+            </a:pPr>
+            <a:r>
+              <a:rPr lang="en-US" sz="1300" dirty="0">
+                <a:solidFill>
+                  <a:schemeClr val="tx1"/>
+                </a:solidFill>
+              </a:rPr>
+              <a:t>EC2 only allows free-tier types → nodes moved to m7i-flex.large (8 GiB).</a:t>
+            </a:r>
+            <a:endParaRPr lang="en-US" sz="1300" dirty="0"/>
+          </a:p>
+        </p:txBody>
+      </p:sp>
+      <p:sp>
+        <p:nvSpPr>
+          <p:cNvPr id="15" name="challenge 3 card"/>
+          <p:cNvSpPr/>
+          <p:nvPr/>
+        </p:nvSpPr>
+        <p:spPr>
+          <a:xfrm>
+            <a:off x="457200" y="2862072"/>
+            <a:ext cx="4023360" cy="1645920"/>
+          </a:xfrm>
+          <a:prstGeom prst="roundRect">
+            <a:avLst>
+              <a:gd name="adj" fmla="val 4444"/>
+            </a:avLst>
+          </a:prstGeom>
+          <a:solidFill>
+            <a:schemeClr val="bg2"/>
+          </a:solidFill>
+          <a:ln/>
+        </p:spPr>
+      </p:sp>
+      <p:sp>
+        <p:nvSpPr>
+          <p:cNvPr id="16" name="challenge 3 chip"/>
+          <p:cNvSpPr/>
+          <p:nvPr/>
+        </p:nvSpPr>
+        <p:spPr>
+          <a:xfrm>
+            <a:off x="640080" y="3063240"/>
+            <a:ext cx="384048" cy="384048"/>
+          </a:xfrm>
+          <a:prstGeom prst="ellipse">
+            <a:avLst/>
+          </a:prstGeom>
+          <a:solidFill>
+            <a:schemeClr val="accent2"/>
+          </a:solidFill>
+          <a:ln/>
+        </p:spPr>
+      </p:sp>
+      <p:sp>
+        <p:nvSpPr>
+          <p:cNvPr id="17" name="challenge 3 number"/>
+          <p:cNvSpPr txBox="1"/>
+          <p:nvPr/>
+        </p:nvSpPr>
+        <p:spPr>
+          <a:xfrm>
+            <a:off x="640080" y="3063240"/>
+            <a:ext cx="384048" cy="384048"/>
+          </a:xfrm>
+          <a:prstGeom prst="rect">
+            <a:avLst/>
+          </a:prstGeom>
+          <a:noFill/>
+          <a:ln/>
+        </p:spPr>
+        <p:txBody>
+          <a:bodyPr wrap="square" lIns="0" tIns="0" rIns="0" bIns="0" rtlCol="0" anchor="ctr"/>
+          <a:lstStyle/>
+          <a:p>
+            <a:pPr algn="ctr" indent="0" marL="0">
+              <a:buNone/>
+            </a:pPr>
+            <a:r>
+              <a:rPr lang="en-US" sz="1300" b="1" dirty="0">
+                <a:solidFill>
+                  <a:schemeClr val="tx1"/>
+                </a:solidFill>
+              </a:rPr>
+              <a:t>3</a:t>
+            </a:r>
+            <a:endParaRPr lang="en-US" sz="1300" dirty="0"/>
+          </a:p>
+        </p:txBody>
+      </p:sp>
+      <p:sp>
+        <p:nvSpPr>
+          <p:cNvPr id="18" name="challenge 3 title"/>
+          <p:cNvSpPr txBox="1"/>
+          <p:nvPr/>
+        </p:nvSpPr>
+        <p:spPr>
+          <a:xfrm>
+            <a:off x="1170432" y="3044952"/>
+            <a:ext cx="3108960" cy="420624"/>
+          </a:xfrm>
+          <a:prstGeom prst="rect">
+            <a:avLst/>
+          </a:prstGeom>
+          <a:noFill/>
+          <a:ln/>
+        </p:spPr>
+        <p:txBody>
+          <a:bodyPr wrap="square" lIns="0" tIns="0" rIns="0" bIns="0" rtlCol="0" anchor="ctr"/>
+          <a:lstStyle/>
+          <a:p>
+            <a:pPr indent="0" marL="0">
+              <a:buNone/>
+            </a:pPr>
+            <a:r>
+              <a:rPr lang="en-US" sz="1500" b="1" dirty="0">
+                <a:solidFill>
+                  <a:schemeClr val="tx2"/>
+                </a:solidFill>
+              </a:rPr>
+              <a:t>CI could not assume AWS role</a:t>
+            </a:r>
+            <a:endParaRPr lang="en-US" sz="1500" dirty="0"/>
+          </a:p>
+        </p:txBody>
+      </p:sp>
+      <p:sp>
+        <p:nvSpPr>
+          <p:cNvPr id="19" name="challenge 3 text"/>
+          <p:cNvSpPr txBox="1"/>
+          <p:nvPr/>
+        </p:nvSpPr>
+        <p:spPr>
+          <a:xfrm>
+            <a:off x="640080" y="3611880"/>
+            <a:ext cx="3657600" cy="777240"/>
+          </a:xfrm>
+          <a:prstGeom prst="rect">
+            <a:avLst/>
+          </a:prstGeom>
+          <a:noFill/>
+          <a:ln/>
+        </p:spPr>
+        <p:txBody>
+          <a:bodyPr wrap="square" lIns="0" tIns="0" rIns="0" bIns="0" rtlCol="0" anchor="t"/>
+          <a:lstStyle/>
+          <a:p>
+            <a:pPr indent="0" marL="0">
+              <a:buNone/>
+            </a:pPr>
+            <a:r>
+              <a:rPr lang="en-US" sz="1300" dirty="0">
+                <a:solidFill>
+                  <a:schemeClr val="tx1"/>
+                </a:solidFill>
+              </a:rPr>
+              <a:t>GitHub sends an immutable OIDC subject → trust policy accepts it, set in Terraform.</a:t>
+            </a:r>
+            <a:endParaRPr lang="en-US" sz="1300" dirty="0"/>
+          </a:p>
+        </p:txBody>
+      </p:sp>
+      <p:sp>
+        <p:nvSpPr>
+          <p:cNvPr id="20" name="challenge 4 card"/>
+          <p:cNvSpPr/>
+          <p:nvPr/>
+        </p:nvSpPr>
+        <p:spPr>
+          <a:xfrm>
+            <a:off x="4663440" y="2862072"/>
+            <a:ext cx="4023360" cy="1645920"/>
+          </a:xfrm>
+          <a:prstGeom prst="roundRect">
+            <a:avLst>
+              <a:gd name="adj" fmla="val 4444"/>
+            </a:avLst>
+          </a:prstGeom>
+          <a:solidFill>
+            <a:schemeClr val="bg2"/>
+          </a:solidFill>
+          <a:ln/>
+        </p:spPr>
+      </p:sp>
+      <p:sp>
+        <p:nvSpPr>
+          <p:cNvPr id="21" name="challenge 4 chip"/>
+          <p:cNvSpPr/>
+          <p:nvPr/>
+        </p:nvSpPr>
+        <p:spPr>
+          <a:xfrm>
+            <a:off x="4846320" y="3063240"/>
+            <a:ext cx="384048" cy="384048"/>
+          </a:xfrm>
+          <a:prstGeom prst="ellipse">
+            <a:avLst/>
+          </a:prstGeom>
+          <a:solidFill>
+            <a:schemeClr val="accent2"/>
+          </a:solidFill>
+          <a:ln/>
+        </p:spPr>
+      </p:sp>
+      <p:sp>
+        <p:nvSpPr>
+          <p:cNvPr id="22" name="challenge 4 number"/>
+          <p:cNvSpPr txBox="1"/>
+          <p:nvPr/>
+        </p:nvSpPr>
+        <p:spPr>
+          <a:xfrm>
+            <a:off x="4846320" y="3063240"/>
+            <a:ext cx="384048" cy="384048"/>
+          </a:xfrm>
+          <a:prstGeom prst="rect">
+            <a:avLst/>
+          </a:prstGeom>
+          <a:noFill/>
+          <a:ln/>
+        </p:spPr>
+        <p:txBody>
+          <a:bodyPr wrap="square" lIns="0" tIns="0" rIns="0" bIns="0" rtlCol="0" anchor="ctr"/>
+          <a:lstStyle/>
+          <a:p>
+            <a:pPr algn="ctr" indent="0" marL="0">
+              <a:buNone/>
+            </a:pPr>
+            <a:r>
+              <a:rPr lang="en-US" sz="1300" b="1" dirty="0">
+                <a:solidFill>
+                  <a:schemeClr val="tx1"/>
+                </a:solidFill>
+              </a:rPr>
+              <a:t>4</a:t>
+            </a:r>
+            <a:endParaRPr lang="en-US" sz="1300" dirty="0"/>
+          </a:p>
+        </p:txBody>
+      </p:sp>
+      <p:sp>
+        <p:nvSpPr>
+          <p:cNvPr id="23" name="challenge 4 title"/>
+          <p:cNvSpPr txBox="1"/>
+          <p:nvPr/>
+        </p:nvSpPr>
+        <p:spPr>
+          <a:xfrm>
+            <a:off x="5376672" y="3044952"/>
+            <a:ext cx="3108960" cy="420624"/>
+          </a:xfrm>
+          <a:prstGeom prst="rect">
+            <a:avLst/>
+          </a:prstGeom>
+          <a:noFill/>
+          <a:ln/>
+        </p:spPr>
+        <p:txBody>
+          <a:bodyPr wrap="square" lIns="0" tIns="0" rIns="0" bIns="0" rtlCol="0" anchor="ctr"/>
+          <a:lstStyle/>
+          <a:p>
+            <a:pPr indent="0" marL="0">
+              <a:buNone/>
+            </a:pPr>
+            <a:r>
+              <a:rPr lang="en-US" sz="1500" b="1" dirty="0">
+                <a:solidFill>
+                  <a:schemeClr val="tx2"/>
+                </a:solidFill>
+              </a:rPr>
+              <a:t>Helm denied the ServiceMonitor</a:t>
+            </a:r>
+            <a:endParaRPr lang="en-US" sz="1500" dirty="0"/>
+          </a:p>
+        </p:txBody>
+      </p:sp>
+      <p:sp>
+        <p:nvSpPr>
+          <p:cNvPr id="24" name="challenge 4 text"/>
+          <p:cNvSpPr txBox="1"/>
+          <p:nvPr/>
+        </p:nvSpPr>
+        <p:spPr>
+          <a:xfrm>
+            <a:off x="4846320" y="3611880"/>
+            <a:ext cx="3657600" cy="777240"/>
+          </a:xfrm>
+          <a:prstGeom prst="rect">
+            <a:avLst/>
+          </a:prstGeom>
+          <a:noFill/>
+          <a:ln/>
+        </p:spPr>
+        <p:txBody>
+          <a:bodyPr wrap="square" lIns="0" tIns="0" rIns="0" bIns="0" rtlCol="0" anchor="t"/>
+          <a:lstStyle/>
+          <a:p>
+            <a:pPr indent="0" marL="0">
+              <a:buNone/>
+            </a:pPr>
+            <a:r>
+              <a:rPr lang="en-US" sz="1300" dirty="0">
+                <a:solidFill>
+                  <a:schemeClr val="tx1"/>
+                </a:solidFill>
+              </a:rPr>
+              <a:t>EKS namespace-admin skips CRDs → small RBAC Role, still least privilege.</a:t>
+            </a:r>
+            <a:endParaRPr lang="en-US" sz="1300" dirty="0"/>
+          </a:p>
+        </p:txBody>
+      </p:sp>
+      <p:sp>
+        <p:nvSpPr>
+          <p:cNvPr id="25" name="Slide Number Placeholder 0"/>
+          <p:cNvSpPr>
+            <a:spLocks noGrp="1"/>
+          </p:cNvSpPr>
+          <p:nvPr>
+            <p:ph type="sldNum" sz="quarter" idx="4294967295"/>
+          </p:nvPr>
+        </p:nvSpPr>
+        <p:spPr>
+          <a:xfrm>
+            <a:off x="8321040" y="4754880"/>
+            <a:ext cx="365760" cy="256032"/>
+          </a:xfrm>
+          <a:prstGeom prst="rect">
+            <a:avLst/>
+          </a:prstGeom>
+          <a:extLst>
+            <a:ext uri="{C572A759-6A51-4108-AA02-DFA0A04FC94B}">
+              <ma14:wrappingTextBoxFlag xmlns:ma14="http://schemas.microsoft.com/office/mac/drawingml/2011/main" val="0"/>
+            </a:ext>
+          </a:extLst>
+        </p:spPr>
+        <p:txBody>
+          <a:bodyPr/>
+          <a:lstStyle>
+            <a:lvl1pPr>
+              <a:defRPr sz="1000">
+                <a:solidFill>
+                  <a:schemeClr val="accent6"/>
+                </a:solidFill>
+              </a:defRPr>
+            </a:lvl1pPr>
+          </a:lstStyle>
+          <a:p>
+            <a:pPr algn="r"/>
+            <a:fld id="{F7021451-1387-4CA6-816F-3879F97B5CBC}" type="slidenum">
+              <a:rPr b="0" lang="en-US"/>
+              <a:t>14</a:t>
+            </a:fld>
+            <a:endParaRPr lang="en-US"/>
+          </a:p>
+        </p:txBody>
+      </p:sp>
+    </p:spTree>
+  </p:cSld>
+  <p:clrMapOvr>
+    <a:masterClrMapping/>
+  </p:clrMapOvr>
+</p:sld>
+</file>
+
+<file path=ppt/slides/slide15.xml><?xml version="1.0" encoding="utf-8"?>
+<p:sld xmlns:a="http://schemas.openxmlformats.org/drawingml/2006/main" xmlns:r="http://schemas.openxmlformats.org/officeDocument/2006/relationships" xmlns:p="http://schemas.openxmlformats.org/presentationml/2006/main">
+  <p:cSld name="Slide 15">
+    <p:spTree>
+      <p:nvGrpSpPr>
+        <p:cNvPr id="1" name=""/>
+        <p:cNvGrpSpPr/>
+        <p:nvPr/>
+      </p:nvGrpSpPr>
+      <p:grpSpPr>
+        <a:xfrm>
+          <a:off x="0" y="0"/>
+          <a:ext cx="0" cy="0"/>
+          <a:chOff x="0" y="0"/>
+          <a:chExt cx="0" cy="0"/>
+        </a:xfrm>
+      </p:grpSpPr>
+      <p:sp>
+        <p:nvSpPr>
           <p:cNvPr id="2" name="Text 0"/>
           <p:cNvSpPr txBox="1"/>
           <p:nvPr/>
@@ -4914,7 +5442,7 @@
                   <a:schemeClr val="bg1"/>
                 </a:solidFill>
               </a:rPr>
-              <a:t>github.com/princekumar0509/devops-heros → session21-python</a:t>
+              <a:t>github.com/princekumar0509/Helpdesk</a:t>
             </a:r>
             <a:endParaRPr lang="en-US" sz="1400" dirty="0"/>
           </a:p>
@@ -4986,7 +5514,7 @@
                   <a:schemeClr val="bg1"/>
                 </a:solidFill>
               </a:rPr>
-              <a:t>session21-python/evidence: screenshots for every module</a:t>
+              <a:t>evidence/ folder: screenshots for every module</a:t>
             </a:r>
             <a:endParaRPr lang="en-US" sz="1400" dirty="0"/>
           </a:p>
@@ -5942,7 +6470,7 @@
                   <a:srgbClr val="FFFFFF"/>
                 </a:solidFill>
               </a:rPr>
-              <a:t>Test · Build · Trivy · Push · Deploy</a:t>
+              <a:t>Test · Build · Trivy · Push · GitOps commit</a:t>
             </a:r>
             <a:endParaRPr lang="en-US" sz="1200" dirty="0"/>
           </a:p>
@@ -6188,7 +6716,7 @@
                   <a:schemeClr val="accent6"/>
                 </a:solidFill>
               </a:rPr>
-              <a:t>EKS 1.34 · namespace helpdesk · Helm release</a:t>
+              <a:t>EKS 1.34 · namespace helpdesk · synced by Argo CD</a:t>
             </a:r>
             <a:endParaRPr lang="en-US" sz="1000" dirty="0"/>
           </a:p>
@@ -6833,7 +7361,7 @@
         <p:spPr>
           <a:xfrm>
             <a:off x="5120640" y="1682496"/>
-            <a:ext cx="1828800" cy="219456"/>
+            <a:ext cx="2377440" cy="219456"/>
           </a:xfrm>
           <a:prstGeom prst="rect">
             <a:avLst/>
@@ -6854,7 +7382,7 @@
                   <a:schemeClr val="accent1"/>
                 </a:solidFill>
               </a:rPr>
-              <a:t>helm upgrade via OIDC</a:t>
+              <a:t>new image tag in Git → Argo CD syncs</a:t>
             </a:r>
             <a:endParaRPr lang="en-US" sz="1000" dirty="0"/>
           </a:p>
@@ -8218,7 +8746,7 @@
                   <a:schemeClr val="tx1"/>
                 </a:solidFill>
               </a:rPr>
-              <a:t>Helm · Ingress · HPA · PVC</a:t>
+              <a:t>Helm · Argo CD · Ingress · HPA</a:t>
             </a:r>
             <a:endParaRPr lang="en-US" sz="1100" dirty="0"/>
           </a:p>
@@ -10258,7 +10786,7 @@
                   <a:srgbClr val="FFFFFF"/>
                 </a:solidFill>
               </a:rPr>
-              <a:t>3 · Deploy</a:t>
+              <a:t>3 · GitOps deploy</a:t>
             </a:r>
             <a:endParaRPr lang="en-US" sz="1200" dirty="0"/>
           </a:p>
@@ -10272,7 +10800,7 @@
                   <a:srgbClr val="FFFFFF"/>
                 </a:solidFill>
               </a:rPr>
-              <a:t>OIDC to AWS → helm upgrade on EKS</a:t>
+              <a:t>commit new tag → Argo CD syncs EKS</a:t>
             </a:r>
             <a:endParaRPr lang="en-US" sz="1200" dirty="0"/>
           </a:p>

</xml_diff>

<commit_message>
docs: add the green Helpdesk pipeline run to the deck and evidence
</commit_message>
<xml_diff>
--- a/demo/HelpDesk-Presentation.pptx
+++ b/demo/HelpDesk-Presentation.pptx
@@ -121,32 +121,32 @@
   <p:extLst>
     <p:ext uri="{521415D9-36F7-43E2-AB2F-B90AF26B5E84}">
       <p14:sectionLst xmlns:p14="http://schemas.microsoft.com/office/powerpoint/2010/main">
-        <p14:section name="Introduction" id="{a51407f5-1ed0-47d0-3336-f2ec08b45cb8}">
+        <p14:section name="Introduction" id="{c9100489-e462-c446-db7c-40d52c7bff31}">
           <p14:sldIdLst>
             <p14:sldId id="256"/>
             <p14:sldId id="257"/>
           </p14:sldIdLst>
         </p14:section>
-        <p14:section name="Architecture" id="{d267dfcd-63d4-91a1-a80a-d39765ae9ca1}">
+        <p14:section name="Architecture" id="{a9feb41b-8d98-e0bb-edb9-2eca009054eb}">
           <p14:sldIdLst>
             <p14:sldId id="258"/>
             <p14:sldId id="259"/>
           </p14:sldIdLst>
         </p14:section>
-        <p14:section name="Build" id="{ca06ab74-505d-f724-acf7-b2294b5a6835}">
+        <p14:section name="Build" id="{5685e07d-0cd0-0772-0267-78a30aedf8d1}">
           <p14:sldIdLst>
             <p14:sldId id="260"/>
             <p14:sldId id="261"/>
             <p14:sldId id="262"/>
           </p14:sldIdLst>
         </p14:section>
-        <p14:section name="Ship" id="{5a7044bc-2eb1-cca2-e1b1-38555e5ee8f2}">
+        <p14:section name="Ship" id="{c9d03fce-ffcc-90c5-9dec-3824060b3695}">
           <p14:sldIdLst>
             <p14:sldId id="263"/>
             <p14:sldId id="264"/>
           </p14:sldIdLst>
         </p14:section>
-        <p14:section name="Run on AWS" id="{622b4e6d-7a05-8801-b2b9-8a81169a09ca}">
+        <p14:section name="Run on AWS" id="{0e55af39-b999-a88c-0d6b-2a2f71c00d84}">
           <p14:sldIdLst>
             <p14:sldId id="265"/>
             <p14:sldId id="266"/>
@@ -154,7 +154,7 @@
             <p14:sldId id="268"/>
           </p14:sldIdLst>
         </p14:section>
-        <p14:section name="Wrap-up" id="{f217e0aa-e41d-705f-a301-0801ea9701bb}">
+        <p14:section name="Wrap-up" id="{b6494ef7-3848-ef2d-ea63-e7556b4695cf}">
           <p14:sldIdLst>
             <p14:sldId id="269"/>
             <p14:sldId id="270"/>

</xml_diff>